<commit_message>
feat: add 5 team members to final slide, remove live url, optimize mobile/projector responsive typography
</commit_message>
<xml_diff>
--- a/frontend/public/YoPharma_Drug_Check_Presentation.pptx
+++ b/frontend/public/YoPharma_Drug_Check_Presentation.pptx
@@ -3488,7 +3488,7 @@
                 <a:ea typeface="Arial" pitchFamily="34" charset="-122"/>
                 <a:cs typeface="Arial" pitchFamily="34" charset="-120"/>
               </a:rPr>
-              <a:t>Pharmacy Innovation &amp; AI Competition | Team PharmaMind • Egyptian Chinese University (ECU)</a:t>
+              <a:t>Team PharmaMind (يوسف محمد • نور عبدالمجيد • رنا ماهر • وفاء طه • نور جمال) | ECU Faculty of Pharmacy</a:t>
             </a:r>
             <a:endParaRPr lang="en-US" sz="850" dirty="0"/>
           </a:p>
@@ -4252,7 +4252,7 @@
                 <a:ea typeface="Arial" pitchFamily="34" charset="-122"/>
                 <a:cs typeface="Arial" pitchFamily="34" charset="-120"/>
               </a:rPr>
-              <a:t>Pharmacy Innovation &amp; AI Competition | Team PharmaMind • Egyptian Chinese University (ECU)</a:t>
+              <a:t>Team PharmaMind (يوسف محمد • نور عبدالمجيد • رنا ماهر • وفاء طه • نور جمال) | ECU Faculty of Pharmacy</a:t>
             </a:r>
             <a:endParaRPr lang="en-US" sz="850" dirty="0"/>
           </a:p>
@@ -4323,7 +4323,7 @@
                 <a:ea typeface="Arial" pitchFamily="34" charset="-122"/>
                 <a:cs typeface="Arial" pitchFamily="34" charset="-120"/>
               </a:rPr>
-              <a:t>FINAL DEMO &amp; COMPETITION SUMMARY</a:t>
+              <a:t>PROJECT CONTRIBUTORS &amp; ACADEMIC TEAM</a:t>
             </a:r>
             <a:endParaRPr lang="en-US" sz="1100" dirty="0"/>
           </a:p>
@@ -4416,7 +4416,7 @@
         <p:spPr>
           <a:xfrm>
             <a:off x="914400" y="2560320"/>
-            <a:ext cx="6583680" cy="3474720"/>
+            <a:ext cx="10332720" cy="3474720"/>
           </a:xfrm>
           <a:prstGeom prst="roundRect">
             <a:avLst>
@@ -4443,26 +4443,23 @@
         <p:spPr>
           <a:xfrm>
             <a:off x="1188720" y="2743200"/>
-            <a:ext cx="6035040" cy="3108960"/>
-          </a:xfrm>
-          <a:prstGeom prst="rect">
-            <a:avLst/>
-          </a:prstGeom>
-          <a:noFill/>
-          <a:ln/>
-        </p:spPr>
-        <p:txBody>
-          <a:bodyPr wrap="square" rtlCol="0" anchor="ctr"/>
-          <a:lstStyle/>
-          <a:p>
-            <a:pPr indent="0" marL="0">
-              <a:lnSpc>
-                <a:spcPts val="1800"/>
-              </a:lnSpc>
-              <a:buNone/>
-            </a:pPr>
-            <a:r>
-              <a:rPr lang="en-US" sz="1300" b="1" dirty="0">
+            <a:ext cx="9784080" cy="320040"/>
+          </a:xfrm>
+          <a:prstGeom prst="rect">
+            <a:avLst/>
+          </a:prstGeom>
+          <a:noFill/>
+          <a:ln/>
+        </p:spPr>
+        <p:txBody>
+          <a:bodyPr wrap="square" rtlCol="0" anchor="ctr"/>
+          <a:lstStyle/>
+          <a:p>
+            <a:pPr indent="0" marL="0">
+              <a:buNone/>
+            </a:pPr>
+            <a:r>
+              <a:rPr lang="en-US" sz="1400" b="1" dirty="0">
                 <a:solidFill>
                   <a:srgbClr val="5EEAD4"/>
                 </a:solidFill>
@@ -4470,219 +4467,9 @@
                 <a:ea typeface="Arial" pitchFamily="34" charset="-122"/>
                 <a:cs typeface="Arial" pitchFamily="34" charset="-120"/>
               </a:rPr>
-              <a:t>🏆  Team &amp; Competition Details:
-</a:t>
-            </a:r>
-            <a:pPr indent="0" marL="0">
-              <a:lnSpc>
-                <a:spcPts val="1800"/>
-              </a:lnSpc>
-              <a:buNone/>
-            </a:pPr>
-            <a:r>
-              <a:rPr lang="en-US" sz="1100" b="1" dirty="0">
-                <a:solidFill>
-                  <a:srgbClr val="FFFFFF"/>
-                </a:solidFill>
-                <a:latin typeface="Arial" pitchFamily="34" charset="0"/>
-                <a:ea typeface="Arial" pitchFamily="34" charset="-122"/>
-                <a:cs typeface="Arial" pitchFamily="34" charset="-120"/>
-              </a:rPr>
-              <a:t>• Team Name: </a:t>
-            </a:r>
-            <a:pPr indent="0" marL="0">
-              <a:lnSpc>
-                <a:spcPts val="1800"/>
-              </a:lnSpc>
-              <a:buNone/>
-            </a:pPr>
-            <a:r>
-              <a:rPr lang="en-US" sz="1100" dirty="0">
-                <a:solidFill>
-                  <a:srgbClr val="FFFFFF"/>
-                </a:solidFill>
-                <a:latin typeface="Arial" pitchFamily="34" charset="0"/>
-                <a:ea typeface="Arial" pitchFamily="34" charset="-122"/>
-                <a:cs typeface="Arial" pitchFamily="34" charset="-120"/>
-              </a:rPr>
-              <a:t>PharmaMind
-</a:t>
-            </a:r>
-            <a:pPr indent="0" marL="0">
-              <a:lnSpc>
-                <a:spcPts val="1800"/>
-              </a:lnSpc>
-              <a:buNone/>
-            </a:pPr>
-            <a:r>
-              <a:rPr lang="en-US" sz="1100" b="1" dirty="0">
-                <a:solidFill>
-                  <a:srgbClr val="FFFFFF"/>
-                </a:solidFill>
-                <a:latin typeface="Arial" pitchFamily="34" charset="0"/>
-                <a:ea typeface="Arial" pitchFamily="34" charset="-122"/>
-                <a:cs typeface="Arial" pitchFamily="34" charset="-120"/>
-              </a:rPr>
-              <a:t>• Competition Track: </a:t>
-            </a:r>
-            <a:pPr indent="0" marL="0">
-              <a:lnSpc>
-                <a:spcPts val="1800"/>
-              </a:lnSpc>
-              <a:buNone/>
-            </a:pPr>
-            <a:r>
-              <a:rPr lang="en-US" sz="1100" dirty="0">
-                <a:solidFill>
-                  <a:srgbClr val="FFFFFF"/>
-                </a:solidFill>
-                <a:latin typeface="Arial" pitchFamily="34" charset="0"/>
-                <a:ea typeface="Arial" pitchFamily="34" charset="-122"/>
-                <a:cs typeface="Arial" pitchFamily="34" charset="-120"/>
-              </a:rPr>
-              <a:t>Pharmacy Innovation &amp; AI
-</a:t>
-            </a:r>
-            <a:pPr indent="0" marL="0">
-              <a:lnSpc>
-                <a:spcPts val="1800"/>
-              </a:lnSpc>
-              <a:buNone/>
-            </a:pPr>
-            <a:r>
-              <a:rPr lang="en-US" sz="1100" b="1" dirty="0">
-                <a:solidFill>
-                  <a:srgbClr val="FFFFFF"/>
-                </a:solidFill>
-                <a:latin typeface="Arial" pitchFamily="34" charset="0"/>
-                <a:ea typeface="Arial" pitchFamily="34" charset="-122"/>
-                <a:cs typeface="Arial" pitchFamily="34" charset="-120"/>
-              </a:rPr>
-              <a:t>• Lead Developer: </a:t>
-            </a:r>
-            <a:pPr indent="0" marL="0">
-              <a:lnSpc>
-                <a:spcPts val="1800"/>
-              </a:lnSpc>
-              <a:buNone/>
-            </a:pPr>
-            <a:r>
-              <a:rPr lang="en-US" sz="1100" dirty="0">
-                <a:solidFill>
-                  <a:srgbClr val="FFFFFF"/>
-                </a:solidFill>
-                <a:latin typeface="Arial" pitchFamily="34" charset="0"/>
-                <a:ea typeface="Arial" pitchFamily="34" charset="-122"/>
-                <a:cs typeface="Arial" pitchFamily="34" charset="-120"/>
-              </a:rPr>
-              <a:t>Youssef Mohamed
-</a:t>
-            </a:r>
-            <a:pPr indent="0" marL="0">
-              <a:lnSpc>
-                <a:spcPts val="1800"/>
-              </a:lnSpc>
-              <a:buNone/>
-            </a:pPr>
-            <a:r>
-              <a:rPr lang="en-US" sz="1100" b="1" dirty="0">
-                <a:solidFill>
-                  <a:srgbClr val="FFFFFF"/>
-                </a:solidFill>
-                <a:latin typeface="Arial" pitchFamily="34" charset="0"/>
-                <a:ea typeface="Arial" pitchFamily="34" charset="-122"/>
-                <a:cs typeface="Arial" pitchFamily="34" charset="-120"/>
-              </a:rPr>
-              <a:t>• Academic Sponsor: </a:t>
-            </a:r>
-            <a:pPr indent="0" marL="0">
-              <a:lnSpc>
-                <a:spcPts val="1800"/>
-              </a:lnSpc>
-              <a:buNone/>
-            </a:pPr>
-            <a:r>
-              <a:rPr lang="en-US" sz="1100" dirty="0">
-                <a:solidFill>
-                  <a:srgbClr val="FFFFFF"/>
-                </a:solidFill>
-                <a:latin typeface="Arial" pitchFamily="34" charset="0"/>
-                <a:ea typeface="Arial" pitchFamily="34" charset="-122"/>
-                <a:cs typeface="Arial" pitchFamily="34" charset="-120"/>
-              </a:rPr>
-              <a:t>Egyptian Chinese University (ECU) — Faculty of Pharmacy
-</a:t>
-            </a:r>
-            <a:pPr indent="0" marL="0">
-              <a:lnSpc>
-                <a:spcPts val="1800"/>
-              </a:lnSpc>
-              <a:buNone/>
-            </a:pPr>
-            <a:r>
-              <a:rPr lang="en-US" sz="1100" b="1" dirty="0">
-                <a:solidFill>
-                  <a:srgbClr val="5EEAD4"/>
-                </a:solidFill>
-                <a:latin typeface="Arial" pitchFamily="34" charset="0"/>
-                <a:ea typeface="Arial" pitchFamily="34" charset="-122"/>
-                <a:cs typeface="Arial" pitchFamily="34" charset="-120"/>
-              </a:rPr>
-              <a:t>• Live Deployed URL: </a:t>
-            </a:r>
-            <a:pPr indent="0" marL="0">
-              <a:lnSpc>
-                <a:spcPts val="1800"/>
-              </a:lnSpc>
-              <a:buNone/>
-            </a:pPr>
-            <a:r>
-              <a:rPr lang="en-US" sz="1100" dirty="0">
-                <a:solidFill>
-                  <a:srgbClr val="FFFFFF"/>
-                </a:solidFill>
-                <a:latin typeface="Arial" pitchFamily="34" charset="0"/>
-                <a:ea typeface="Arial" pitchFamily="34" charset="-122"/>
-                <a:cs typeface="Arial" pitchFamily="34" charset="-120"/>
-              </a:rPr>
-              <a:t>https://web1111-three.vercel.app
-</a:t>
-            </a:r>
-            <a:pPr indent="0" marL="0">
-              <a:lnSpc>
-                <a:spcPts val="1800"/>
-              </a:lnSpc>
-              <a:buNone/>
-            </a:pPr>
-            <a:r>
-              <a:rPr lang="en-US" sz="1100" b="1" dirty="0">
-                <a:solidFill>
-                  <a:srgbClr val="5EEAD4"/>
-                </a:solidFill>
-                <a:latin typeface="Arial" pitchFamily="34" charset="0"/>
-                <a:ea typeface="Arial" pitchFamily="34" charset="-122"/>
-                <a:cs typeface="Arial" pitchFamily="34" charset="-120"/>
-              </a:rPr>
-              <a:t>• Interactive Slide Deck: </a:t>
-            </a:r>
-            <a:pPr indent="0" marL="0">
-              <a:lnSpc>
-                <a:spcPts val="1800"/>
-              </a:lnSpc>
-              <a:buNone/>
-            </a:pPr>
-            <a:r>
-              <a:rPr lang="en-US" sz="1100" dirty="0">
-                <a:solidFill>
-                  <a:srgbClr val="FFFFFF"/>
-                </a:solidFill>
-                <a:latin typeface="Arial" pitchFamily="34" charset="0"/>
-                <a:ea typeface="Arial" pitchFamily="34" charset="-122"/>
-                <a:cs typeface="Arial" pitchFamily="34" charset="-120"/>
-              </a:rPr>
-              <a:t>https://web1111-three.vercel.app/presentation.html</a:t>
-            </a:r>
-            <a:endParaRPr lang="en-US" sz="1100" dirty="0"/>
+              <a:t>🏆  فريق العمل المشارك في تطوير وتصميم المنصة (Team PharmaMind):</a:t>
+            </a:r>
+            <a:endParaRPr lang="en-US" sz="1400" dirty="0"/>
           </a:p>
         </p:txBody>
       </p:sp>
@@ -4694,18 +4481,18 @@
         </p:nvSpPr>
         <p:spPr>
           <a:xfrm>
-            <a:off x="7772400" y="2560320"/>
-            <a:ext cx="3474720" cy="3474720"/>
+            <a:off x="1188720" y="3200400"/>
+            <a:ext cx="4663440" cy="731520"/>
           </a:xfrm>
           <a:prstGeom prst="roundRect">
             <a:avLst>
-              <a:gd name="adj" fmla="val 3158"/>
+              <a:gd name="adj" fmla="val 10000"/>
             </a:avLst>
           </a:prstGeom>
           <a:solidFill>
-            <a:srgbClr val="134E4A"/>
+            <a:srgbClr val="0F172A"/>
           </a:solidFill>
-          <a:ln w="19050">
+          <a:ln w="12700">
             <a:solidFill>
               <a:srgbClr val="0D9488"/>
             </a:solidFill>
@@ -4715,26 +4502,104 @@
       </p:sp>
       <p:sp>
         <p:nvSpPr>
-          <p:cNvPr id="8" name="Shape 6"/>
-          <p:cNvSpPr/>
-          <p:nvPr/>
-        </p:nvSpPr>
-        <p:spPr>
-          <a:xfrm>
-            <a:off x="8503920" y="2834640"/>
-            <a:ext cx="2011680" cy="2011680"/>
+          <p:cNvPr id="8" name="Text 6"/>
+          <p:cNvSpPr/>
+          <p:nvPr/>
+        </p:nvSpPr>
+        <p:spPr>
+          <a:xfrm>
+            <a:off x="1371600" y="3291840"/>
+            <a:ext cx="4297680" cy="274320"/>
+          </a:xfrm>
+          <a:prstGeom prst="rect">
+            <a:avLst/>
+          </a:prstGeom>
+          <a:noFill/>
+          <a:ln/>
+        </p:spPr>
+        <p:txBody>
+          <a:bodyPr wrap="square" rtlCol="0" anchor="ctr"/>
+          <a:lstStyle/>
+          <a:p>
+            <a:pPr indent="0" marL="0">
+              <a:buNone/>
+            </a:pPr>
+            <a:r>
+              <a:rPr lang="en-US" sz="1100" b="1" dirty="0">
+                <a:solidFill>
+                  <a:srgbClr val="FFFFFF"/>
+                </a:solidFill>
+                <a:latin typeface="Arial" pitchFamily="34" charset="0"/>
+                <a:ea typeface="Arial" pitchFamily="34" charset="-122"/>
+                <a:cs typeface="Arial" pitchFamily="34" charset="-120"/>
+              </a:rPr>
+              <a:t>1. يوسف محمد (Youssef Mohamed)</a:t>
+            </a:r>
+            <a:endParaRPr lang="en-US" sz="1100" dirty="0"/>
+          </a:p>
+        </p:txBody>
+      </p:sp>
+      <p:sp>
+        <p:nvSpPr>
+          <p:cNvPr id="9" name="Text 7"/>
+          <p:cNvSpPr/>
+          <p:nvPr/>
+        </p:nvSpPr>
+        <p:spPr>
+          <a:xfrm>
+            <a:off x="1371600" y="3566160"/>
+            <a:ext cx="4297680" cy="274320"/>
+          </a:xfrm>
+          <a:prstGeom prst="rect">
+            <a:avLst/>
+          </a:prstGeom>
+          <a:noFill/>
+          <a:ln/>
+        </p:spPr>
+        <p:txBody>
+          <a:bodyPr wrap="square" rtlCol="0" anchor="ctr"/>
+          <a:lstStyle/>
+          <a:p>
+            <a:pPr indent="0" marL="0">
+              <a:buNone/>
+            </a:pPr>
+            <a:r>
+              <a:rPr lang="en-US" sz="950" dirty="0">
+                <a:solidFill>
+                  <a:srgbClr val="94A3B8"/>
+                </a:solidFill>
+                <a:latin typeface="Arial" pitchFamily="34" charset="0"/>
+                <a:ea typeface="Arial" pitchFamily="34" charset="-122"/>
+                <a:cs typeface="Arial" pitchFamily="34" charset="-120"/>
+              </a:rPr>
+              <a:t>Full-Stack Architecture &amp; AI Integration</a:t>
+            </a:r>
+            <a:endParaRPr lang="en-US" sz="950" dirty="0"/>
+          </a:p>
+        </p:txBody>
+      </p:sp>
+      <p:sp>
+        <p:nvSpPr>
+          <p:cNvPr id="10" name="Shape 8"/>
+          <p:cNvSpPr/>
+          <p:nvPr/>
+        </p:nvSpPr>
+        <p:spPr>
+          <a:xfrm>
+            <a:off x="6126480" y="3200400"/>
+            <a:ext cx="4663440" cy="731520"/>
           </a:xfrm>
           <a:prstGeom prst="roundRect">
             <a:avLst>
-              <a:gd name="adj" fmla="val 4545"/>
+              <a:gd name="adj" fmla="val 10000"/>
             </a:avLst>
           </a:prstGeom>
           <a:solidFill>
-            <a:srgbClr val="FFFFFF"/>
+            <a:srgbClr val="0F172A"/>
           </a:solidFill>
           <a:ln w="12700">
             <a:solidFill>
-              <a:srgbClr val="CBD5E1"/>
+              <a:srgbClr val="0D9488"/>
             </a:solidFill>
             <a:prstDash val="solid"/>
           </a:ln>
@@ -4742,14 +4607,407 @@
       </p:sp>
       <p:sp>
         <p:nvSpPr>
-          <p:cNvPr id="9" name="Text 7"/>
-          <p:cNvSpPr/>
-          <p:nvPr/>
-        </p:nvSpPr>
-        <p:spPr>
-          <a:xfrm>
-            <a:off x="8503920" y="3566160"/>
-            <a:ext cx="2011680" cy="548640"/>
+          <p:cNvPr id="11" name="Text 9"/>
+          <p:cNvSpPr/>
+          <p:nvPr/>
+        </p:nvSpPr>
+        <p:spPr>
+          <a:xfrm>
+            <a:off x="6309360" y="3291840"/>
+            <a:ext cx="4297680" cy="274320"/>
+          </a:xfrm>
+          <a:prstGeom prst="rect">
+            <a:avLst/>
+          </a:prstGeom>
+          <a:noFill/>
+          <a:ln/>
+        </p:spPr>
+        <p:txBody>
+          <a:bodyPr wrap="square" rtlCol="0" anchor="ctr"/>
+          <a:lstStyle/>
+          <a:p>
+            <a:pPr indent="0" marL="0">
+              <a:buNone/>
+            </a:pPr>
+            <a:r>
+              <a:rPr lang="en-US" sz="1100" b="1" dirty="0">
+                <a:solidFill>
+                  <a:srgbClr val="FFFFFF"/>
+                </a:solidFill>
+                <a:latin typeface="Arial" pitchFamily="34" charset="0"/>
+                <a:ea typeface="Arial" pitchFamily="34" charset="-122"/>
+                <a:cs typeface="Arial" pitchFamily="34" charset="-120"/>
+              </a:rPr>
+              <a:t>2. نور عبدالمجيد (Nour Abdelmageed)</a:t>
+            </a:r>
+            <a:endParaRPr lang="en-US" sz="1100" dirty="0"/>
+          </a:p>
+        </p:txBody>
+      </p:sp>
+      <p:sp>
+        <p:nvSpPr>
+          <p:cNvPr id="12" name="Text 10"/>
+          <p:cNvSpPr/>
+          <p:nvPr/>
+        </p:nvSpPr>
+        <p:spPr>
+          <a:xfrm>
+            <a:off x="6309360" y="3566160"/>
+            <a:ext cx="4297680" cy="274320"/>
+          </a:xfrm>
+          <a:prstGeom prst="rect">
+            <a:avLst/>
+          </a:prstGeom>
+          <a:noFill/>
+          <a:ln/>
+        </p:spPr>
+        <p:txBody>
+          <a:bodyPr wrap="square" rtlCol="0" anchor="ctr"/>
+          <a:lstStyle/>
+          <a:p>
+            <a:pPr indent="0" marL="0">
+              <a:buNone/>
+            </a:pPr>
+            <a:r>
+              <a:rPr lang="en-US" sz="950" dirty="0">
+                <a:solidFill>
+                  <a:srgbClr val="94A3B8"/>
+                </a:solidFill>
+                <a:latin typeface="Arial" pitchFamily="34" charset="0"/>
+                <a:ea typeface="Arial" pitchFamily="34" charset="-122"/>
+                <a:cs typeface="Arial" pitchFamily="34" charset="-120"/>
+              </a:rPr>
+              <a:t>Clinical Pharmacy Research &amp; Interaction Matrix</a:t>
+            </a:r>
+            <a:endParaRPr lang="en-US" sz="950" dirty="0"/>
+          </a:p>
+        </p:txBody>
+      </p:sp>
+      <p:sp>
+        <p:nvSpPr>
+          <p:cNvPr id="13" name="Shape 11"/>
+          <p:cNvSpPr/>
+          <p:nvPr/>
+        </p:nvSpPr>
+        <p:spPr>
+          <a:xfrm>
+            <a:off x="1188720" y="4069080"/>
+            <a:ext cx="4663440" cy="731520"/>
+          </a:xfrm>
+          <a:prstGeom prst="roundRect">
+            <a:avLst>
+              <a:gd name="adj" fmla="val 10000"/>
+            </a:avLst>
+          </a:prstGeom>
+          <a:solidFill>
+            <a:srgbClr val="0F172A"/>
+          </a:solidFill>
+          <a:ln w="12700">
+            <a:solidFill>
+              <a:srgbClr val="0D9488"/>
+            </a:solidFill>
+            <a:prstDash val="solid"/>
+          </a:ln>
+        </p:spPr>
+      </p:sp>
+      <p:sp>
+        <p:nvSpPr>
+          <p:cNvPr id="14" name="Text 12"/>
+          <p:cNvSpPr/>
+          <p:nvPr/>
+        </p:nvSpPr>
+        <p:spPr>
+          <a:xfrm>
+            <a:off x="1371600" y="4160520"/>
+            <a:ext cx="4297680" cy="274320"/>
+          </a:xfrm>
+          <a:prstGeom prst="rect">
+            <a:avLst/>
+          </a:prstGeom>
+          <a:noFill/>
+          <a:ln/>
+        </p:spPr>
+        <p:txBody>
+          <a:bodyPr wrap="square" rtlCol="0" anchor="ctr"/>
+          <a:lstStyle/>
+          <a:p>
+            <a:pPr indent="0" marL="0">
+              <a:buNone/>
+            </a:pPr>
+            <a:r>
+              <a:rPr lang="en-US" sz="1100" b="1" dirty="0">
+                <a:solidFill>
+                  <a:srgbClr val="FFFFFF"/>
+                </a:solidFill>
+                <a:latin typeface="Arial" pitchFamily="34" charset="0"/>
+                <a:ea typeface="Arial" pitchFamily="34" charset="-122"/>
+                <a:cs typeface="Arial" pitchFamily="34" charset="-120"/>
+              </a:rPr>
+              <a:t>3. رنا ماهر (Rana Maher)</a:t>
+            </a:r>
+            <a:endParaRPr lang="en-US" sz="1100" dirty="0"/>
+          </a:p>
+        </p:txBody>
+      </p:sp>
+      <p:sp>
+        <p:nvSpPr>
+          <p:cNvPr id="15" name="Text 13"/>
+          <p:cNvSpPr/>
+          <p:nvPr/>
+        </p:nvSpPr>
+        <p:spPr>
+          <a:xfrm>
+            <a:off x="1371600" y="4434840"/>
+            <a:ext cx="4297680" cy="274320"/>
+          </a:xfrm>
+          <a:prstGeom prst="rect">
+            <a:avLst/>
+          </a:prstGeom>
+          <a:noFill/>
+          <a:ln/>
+        </p:spPr>
+        <p:txBody>
+          <a:bodyPr wrap="square" rtlCol="0" anchor="ctr"/>
+          <a:lstStyle/>
+          <a:p>
+            <a:pPr indent="0" marL="0">
+              <a:buNone/>
+            </a:pPr>
+            <a:r>
+              <a:rPr lang="en-US" sz="950" dirty="0">
+                <a:solidFill>
+                  <a:srgbClr val="94A3B8"/>
+                </a:solidFill>
+                <a:latin typeface="Arial" pitchFamily="34" charset="0"/>
+                <a:ea typeface="Arial" pitchFamily="34" charset="-122"/>
+                <a:cs typeface="Arial" pitchFamily="34" charset="-120"/>
+              </a:rPr>
+              <a:t>Drug Database Curation &amp; Egyptian Generics</a:t>
+            </a:r>
+            <a:endParaRPr lang="en-US" sz="950" dirty="0"/>
+          </a:p>
+        </p:txBody>
+      </p:sp>
+      <p:sp>
+        <p:nvSpPr>
+          <p:cNvPr id="16" name="Shape 14"/>
+          <p:cNvSpPr/>
+          <p:nvPr/>
+        </p:nvSpPr>
+        <p:spPr>
+          <a:xfrm>
+            <a:off x="6126480" y="4069080"/>
+            <a:ext cx="4663440" cy="731520"/>
+          </a:xfrm>
+          <a:prstGeom prst="roundRect">
+            <a:avLst>
+              <a:gd name="adj" fmla="val 10000"/>
+            </a:avLst>
+          </a:prstGeom>
+          <a:solidFill>
+            <a:srgbClr val="0F172A"/>
+          </a:solidFill>
+          <a:ln w="12700">
+            <a:solidFill>
+              <a:srgbClr val="0D9488"/>
+            </a:solidFill>
+            <a:prstDash val="solid"/>
+          </a:ln>
+        </p:spPr>
+      </p:sp>
+      <p:sp>
+        <p:nvSpPr>
+          <p:cNvPr id="17" name="Text 15"/>
+          <p:cNvSpPr/>
+          <p:nvPr/>
+        </p:nvSpPr>
+        <p:spPr>
+          <a:xfrm>
+            <a:off x="6309360" y="4160520"/>
+            <a:ext cx="4297680" cy="274320"/>
+          </a:xfrm>
+          <a:prstGeom prst="rect">
+            <a:avLst/>
+          </a:prstGeom>
+          <a:noFill/>
+          <a:ln/>
+        </p:spPr>
+        <p:txBody>
+          <a:bodyPr wrap="square" rtlCol="0" anchor="ctr"/>
+          <a:lstStyle/>
+          <a:p>
+            <a:pPr indent="0" marL="0">
+              <a:buNone/>
+            </a:pPr>
+            <a:r>
+              <a:rPr lang="en-US" sz="1100" b="1" dirty="0">
+                <a:solidFill>
+                  <a:srgbClr val="FFFFFF"/>
+                </a:solidFill>
+                <a:latin typeface="Arial" pitchFamily="34" charset="0"/>
+                <a:ea typeface="Arial" pitchFamily="34" charset="-122"/>
+                <a:cs typeface="Arial" pitchFamily="34" charset="-120"/>
+              </a:rPr>
+              <a:t>4. وفاء طه (Wafaa Taha)</a:t>
+            </a:r>
+            <a:endParaRPr lang="en-US" sz="1100" dirty="0"/>
+          </a:p>
+        </p:txBody>
+      </p:sp>
+      <p:sp>
+        <p:nvSpPr>
+          <p:cNvPr id="18" name="Text 16"/>
+          <p:cNvSpPr/>
+          <p:nvPr/>
+        </p:nvSpPr>
+        <p:spPr>
+          <a:xfrm>
+            <a:off x="6309360" y="4434840"/>
+            <a:ext cx="4297680" cy="274320"/>
+          </a:xfrm>
+          <a:prstGeom prst="rect">
+            <a:avLst/>
+          </a:prstGeom>
+          <a:noFill/>
+          <a:ln/>
+        </p:spPr>
+        <p:txBody>
+          <a:bodyPr wrap="square" rtlCol="0" anchor="ctr"/>
+          <a:lstStyle/>
+          <a:p>
+            <a:pPr indent="0" marL="0">
+              <a:buNone/>
+            </a:pPr>
+            <a:r>
+              <a:rPr lang="en-US" sz="950" dirty="0">
+                <a:solidFill>
+                  <a:srgbClr val="94A3B8"/>
+                </a:solidFill>
+                <a:latin typeface="Arial" pitchFamily="34" charset="0"/>
+                <a:ea typeface="Arial" pitchFamily="34" charset="-122"/>
+                <a:cs typeface="Arial" pitchFamily="34" charset="-120"/>
+              </a:rPr>
+              <a:t>Biomarkers &amp; Clinical Lab Normal Ranges</a:t>
+            </a:r>
+            <a:endParaRPr lang="en-US" sz="950" dirty="0"/>
+          </a:p>
+        </p:txBody>
+      </p:sp>
+      <p:sp>
+        <p:nvSpPr>
+          <p:cNvPr id="19" name="Shape 17"/>
+          <p:cNvSpPr/>
+          <p:nvPr/>
+        </p:nvSpPr>
+        <p:spPr>
+          <a:xfrm>
+            <a:off x="1188720" y="4937760"/>
+            <a:ext cx="4663440" cy="731520"/>
+          </a:xfrm>
+          <a:prstGeom prst="roundRect">
+            <a:avLst>
+              <a:gd name="adj" fmla="val 10000"/>
+            </a:avLst>
+          </a:prstGeom>
+          <a:solidFill>
+            <a:srgbClr val="0F172A"/>
+          </a:solidFill>
+          <a:ln w="12700">
+            <a:solidFill>
+              <a:srgbClr val="0D9488"/>
+            </a:solidFill>
+            <a:prstDash val="solid"/>
+          </a:ln>
+        </p:spPr>
+      </p:sp>
+      <p:sp>
+        <p:nvSpPr>
+          <p:cNvPr id="20" name="Text 18"/>
+          <p:cNvSpPr/>
+          <p:nvPr/>
+        </p:nvSpPr>
+        <p:spPr>
+          <a:xfrm>
+            <a:off x="1371600" y="5029200"/>
+            <a:ext cx="4297680" cy="274320"/>
+          </a:xfrm>
+          <a:prstGeom prst="rect">
+            <a:avLst/>
+          </a:prstGeom>
+          <a:noFill/>
+          <a:ln/>
+        </p:spPr>
+        <p:txBody>
+          <a:bodyPr wrap="square" rtlCol="0" anchor="ctr"/>
+          <a:lstStyle/>
+          <a:p>
+            <a:pPr indent="0" marL="0">
+              <a:buNone/>
+            </a:pPr>
+            <a:r>
+              <a:rPr lang="en-US" sz="1100" b="1" dirty="0">
+                <a:solidFill>
+                  <a:srgbClr val="FFFFFF"/>
+                </a:solidFill>
+                <a:latin typeface="Arial" pitchFamily="34" charset="0"/>
+                <a:ea typeface="Arial" pitchFamily="34" charset="-122"/>
+                <a:cs typeface="Arial" pitchFamily="34" charset="-120"/>
+              </a:rPr>
+              <a:t>5. نور جمال (Nour Gamal)</a:t>
+            </a:r>
+            <a:endParaRPr lang="en-US" sz="1100" dirty="0"/>
+          </a:p>
+        </p:txBody>
+      </p:sp>
+      <p:sp>
+        <p:nvSpPr>
+          <p:cNvPr id="21" name="Text 19"/>
+          <p:cNvSpPr/>
+          <p:nvPr/>
+        </p:nvSpPr>
+        <p:spPr>
+          <a:xfrm>
+            <a:off x="1371600" y="5303520"/>
+            <a:ext cx="4297680" cy="274320"/>
+          </a:xfrm>
+          <a:prstGeom prst="rect">
+            <a:avLst/>
+          </a:prstGeom>
+          <a:noFill/>
+          <a:ln/>
+        </p:spPr>
+        <p:txBody>
+          <a:bodyPr wrap="square" rtlCol="0" anchor="ctr"/>
+          <a:lstStyle/>
+          <a:p>
+            <a:pPr indent="0" marL="0">
+              <a:buNone/>
+            </a:pPr>
+            <a:r>
+              <a:rPr lang="en-US" sz="950" dirty="0">
+                <a:solidFill>
+                  <a:srgbClr val="94A3B8"/>
+                </a:solidFill>
+                <a:latin typeface="Arial" pitchFamily="34" charset="0"/>
+                <a:ea typeface="Arial" pitchFamily="34" charset="-122"/>
+                <a:cs typeface="Arial" pitchFamily="34" charset="-120"/>
+              </a:rPr>
+              <a:t>Food-Drug Interactions &amp; Dietary Guidelines</a:t>
+            </a:r>
+            <a:endParaRPr lang="en-US" sz="950" dirty="0"/>
+          </a:p>
+        </p:txBody>
+      </p:sp>
+      <p:sp>
+        <p:nvSpPr>
+          <p:cNvPr id="22" name="Text 20"/>
+          <p:cNvSpPr/>
+          <p:nvPr/>
+        </p:nvSpPr>
+        <p:spPr>
+          <a:xfrm>
+            <a:off x="1188720" y="5623560"/>
+            <a:ext cx="9784080" cy="274320"/>
           </a:xfrm>
           <a:prstGeom prst="rect">
             <a:avLst/>
@@ -4765,66 +5023,7 @@
               <a:buNone/>
             </a:pPr>
             <a:r>
-              <a:rPr lang="en-US" sz="1100" b="1" dirty="0">
-                <a:solidFill>
-                  <a:srgbClr val="0F172A"/>
-                </a:solidFill>
-                <a:latin typeface="Arial" pitchFamily="34" charset="0"/>
-                <a:ea typeface="Arial" pitchFamily="34" charset="-122"/>
-                <a:cs typeface="Arial" pitchFamily="34" charset="-120"/>
-              </a:rPr>
-              <a:t>SCAN QR</a:t>
-            </a:r>
-            <a:endParaRPr lang="en-US" sz="1100" dirty="0"/>
-          </a:p>
-          <a:p>
-            <a:pPr algn="ctr" indent="0" marL="0">
-              <a:buNone/>
-            </a:pPr>
-            <a:r>
-              <a:rPr lang="en-US" sz="1100" b="1" dirty="0">
-                <a:solidFill>
-                  <a:srgbClr val="0F172A"/>
-                </a:solidFill>
-                <a:latin typeface="Arial" pitchFamily="34" charset="0"/>
-                <a:ea typeface="Arial" pitchFamily="34" charset="-122"/>
-                <a:cs typeface="Arial" pitchFamily="34" charset="-120"/>
-              </a:rPr>
-              <a:t>TO TRY LIVE</a:t>
-            </a:r>
-            <a:endParaRPr lang="en-US" sz="1100" dirty="0"/>
-          </a:p>
-        </p:txBody>
-      </p:sp>
-      <p:sp>
-        <p:nvSpPr>
-          <p:cNvPr id="10" name="Text 8"/>
-          <p:cNvSpPr/>
-          <p:nvPr/>
-        </p:nvSpPr>
-        <p:spPr>
-          <a:xfrm>
-            <a:off x="7955280" y="5029200"/>
-            <a:ext cx="3108960" cy="731520"/>
-          </a:xfrm>
-          <a:prstGeom prst="rect">
-            <a:avLst/>
-          </a:prstGeom>
-          <a:noFill/>
-          <a:ln/>
-        </p:spPr>
-        <p:txBody>
-          <a:bodyPr wrap="square" rtlCol="0" anchor="ctr"/>
-          <a:lstStyle/>
-          <a:p>
-            <a:pPr algn="ctr" indent="0" marL="0">
-              <a:lnSpc>
-                <a:spcPts val="1500"/>
-              </a:lnSpc>
-              <a:buNone/>
-            </a:pPr>
-            <a:r>
-              <a:rPr lang="en-US" sz="1100" b="1" dirty="0">
+              <a:rPr lang="en-US" sz="1050" b="1" dirty="0">
                 <a:solidFill>
                   <a:srgbClr val="5EEAD4"/>
                 </a:solidFill>
@@ -4832,29 +5031,9 @@
                 <a:ea typeface="Arial" pitchFamily="34" charset="-122"/>
                 <a:cs typeface="Arial" pitchFamily="34" charset="-120"/>
               </a:rPr>
-              <a:t>Scan for Live Demo</a:t>
-            </a:r>
-            <a:endParaRPr lang="en-US" sz="1100" dirty="0"/>
-          </a:p>
-          <a:p>
-            <a:pPr algn="ctr" indent="0" marL="0">
-              <a:lnSpc>
-                <a:spcPts val="1500"/>
-              </a:lnSpc>
-              <a:buNone/>
-            </a:pPr>
-            <a:r>
-              <a:rPr lang="en-US" sz="1100" b="1" dirty="0">
-                <a:solidFill>
-                  <a:srgbClr val="5EEAD4"/>
-                </a:solidFill>
-                <a:latin typeface="Arial" pitchFamily="34" charset="0"/>
-                <a:ea typeface="Arial" pitchFamily="34" charset="-122"/>
-                <a:cs typeface="Arial" pitchFamily="34" charset="-120"/>
-              </a:rPr>
-              <a:t>YoPharma Platform</a:t>
-            </a:r>
-            <a:endParaRPr lang="en-US" sz="1100" dirty="0"/>
+              <a:t>Faculty of Pharmacy — Egyptian Chinese University (ECU) • كلية الصيدلة بالجامعة المصرية الصينية</a:t>
+            </a:r>
+            <a:endParaRPr lang="en-US" sz="1050" dirty="0"/>
           </a:p>
         </p:txBody>
       </p:sp>
@@ -5762,7 +5941,7 @@
                 <a:ea typeface="Arial" pitchFamily="34" charset="-122"/>
                 <a:cs typeface="Arial" pitchFamily="34" charset="-120"/>
               </a:rPr>
-              <a:t>Pharmacy Innovation &amp; AI Competition | Team PharmaMind • Egyptian Chinese University (ECU)</a:t>
+              <a:t>Team PharmaMind (يوسف محمد • نور عبدالمجيد • رنا ماهر • وفاء طه • نور جمال) | ECU Faculty of Pharmacy</a:t>
             </a:r>
             <a:endParaRPr lang="en-US" sz="850" dirty="0"/>
           </a:p>
@@ -7662,7 +7841,7 @@
                 <a:ea typeface="Arial" pitchFamily="34" charset="-122"/>
                 <a:cs typeface="Arial" pitchFamily="34" charset="-120"/>
               </a:rPr>
-              <a:t>Pharmacy Innovation &amp; AI Competition | Team PharmaMind • Egyptian Chinese University (ECU)</a:t>
+              <a:t>Team PharmaMind (يوسف محمد • نور عبدالمجيد • رنا ماهر • وفاء طه • نور جمال) | ECU Faculty of Pharmacy</a:t>
             </a:r>
             <a:endParaRPr lang="en-US" sz="850" dirty="0"/>
           </a:p>
@@ -8511,7 +8690,7 @@
                 <a:ea typeface="Arial" pitchFamily="34" charset="-122"/>
                 <a:cs typeface="Arial" pitchFamily="34" charset="-120"/>
               </a:rPr>
-              <a:t>Pharmacy Innovation &amp; AI Competition | Team PharmaMind • Egyptian Chinese University (ECU)</a:t>
+              <a:t>Team PharmaMind (يوسف محمد • نور عبدالمجيد • رنا ماهر • وفاء طه • نور جمال) | ECU Faculty of Pharmacy</a:t>
             </a:r>
             <a:endParaRPr lang="en-US" sz="850" dirty="0"/>
           </a:p>
@@ -9640,7 +9819,7 @@
                 <a:ea typeface="Arial" pitchFamily="34" charset="-122"/>
                 <a:cs typeface="Arial" pitchFamily="34" charset="-120"/>
               </a:rPr>
-              <a:t>Pharmacy Innovation &amp; AI Competition | Team PharmaMind • Egyptian Chinese University (ECU)</a:t>
+              <a:t>Team PharmaMind (يوسف محمد • نور عبدالمجيد • رنا ماهر • وفاء طه • نور جمال) | ECU Faculty of Pharmacy</a:t>
             </a:r>
             <a:endParaRPr lang="en-US" sz="850" dirty="0"/>
           </a:p>
@@ -10742,7 +10921,7 @@
                 <a:ea typeface="Arial" pitchFamily="34" charset="-122"/>
                 <a:cs typeface="Arial" pitchFamily="34" charset="-120"/>
               </a:rPr>
-              <a:t>Pharmacy Innovation &amp; AI Competition | Team PharmaMind • Egyptian Chinese University (ECU)</a:t>
+              <a:t>Team PharmaMind (يوسف محمد • نور عبدالمجيد • رنا ماهر • وفاء طه • نور جمال) | ECU Faculty of Pharmacy</a:t>
             </a:r>
             <a:endParaRPr lang="en-US" sz="850" dirty="0"/>
           </a:p>
@@ -11922,7 +12101,7 @@
                 <a:ea typeface="Arial" pitchFamily="34" charset="-122"/>
                 <a:cs typeface="Arial" pitchFamily="34" charset="-120"/>
               </a:rPr>
-              <a:t>Pharmacy Innovation &amp; AI Competition | Team PharmaMind • Egyptian Chinese University (ECU)</a:t>
+              <a:t>Team PharmaMind (يوسف محمد • نور عبدالمجيد • رنا ماهر • وفاء طه • نور جمال) | ECU Faculty of Pharmacy</a:t>
             </a:r>
             <a:endParaRPr lang="en-US" sz="850" dirty="0"/>
           </a:p>
@@ -12929,7 +13108,7 @@
                 <a:ea typeface="Arial" pitchFamily="34" charset="-122"/>
                 <a:cs typeface="Arial" pitchFamily="34" charset="-120"/>
               </a:rPr>
-              <a:t>Pharmacy Innovation &amp; AI Competition | Team PharmaMind • Egyptian Chinese University (ECU)</a:t>
+              <a:t>Team PharmaMind (يوسف محمد • نور عبدالمجيد • رنا ماهر • وفاء طه • نور جمال) | ECU Faculty of Pharmacy</a:t>
             </a:r>
             <a:endParaRPr lang="en-US" sz="850" dirty="0"/>
           </a:p>
@@ -13689,7 +13868,7 @@
                 <a:ea typeface="Arial" pitchFamily="34" charset="-122"/>
                 <a:cs typeface="Arial" pitchFamily="34" charset="-120"/>
               </a:rPr>
-              <a:t>Pharmacy Innovation &amp; AI Competition | Team PharmaMind • Egyptian Chinese University (ECU)</a:t>
+              <a:t>Team PharmaMind (يوسف محمد • نور عبدالمجيد • رنا ماهر • وفاء طه • نور جمال) | ECU Faculty of Pharmacy</a:t>
             </a:r>
             <a:endParaRPr lang="en-US" sz="850" dirty="0"/>
           </a:p>

</xml_diff>